<commit_message>
Update weekly report research positioning
</commit_message>
<xml_diff>
--- a/reports/2026-04/meeting_260424/weekly_report_260427.pptx
+++ b/reports/2026-04/meeting_260424/weekly_report_260427.pptx
@@ -3326,7 +3326,7 @@
                 </a:solidFill>
                 <a:latin typeface="Microsoft JhengHei UI"/>
               </a:rPr>
-              <a:t>一句話：先量化 runtime 成本，再讓新架構從數據裡長出來。</a:t>
+              <a:t>一句話：用 software 做到盡可能快，找出 producer-consumer 的真正瓶頸。</a:t>
             </a:r>
           </a:p>
         </p:txBody>
@@ -3827,7 +3827,7 @@
                 </a:solidFill>
                 <a:latin typeface="Microsoft JhengHei"/>
               </a:rPr>
-              <a:t>以 metrics/profiling loop 建 baseline，再比較 batch、local queue、dynamic role 等 runtime variants。</a:t>
+              <a:t>Software producer-consumer 做到盡可能快；用 metrics/profiling 找瓶頸，給出 optimization 方向。</a:t>
             </a:r>
           </a:p>
         </p:txBody>
@@ -4593,7 +4593,7 @@
                 </a:solidFill>
                 <a:latin typeface="Microsoft JhengHei"/>
               </a:rPr>
-              <a:t>Metrics loop 提供證據；architecture proposal 解釋哪些成本需要 runtime/API/hardware support。</a:t>
+              <a:t>Metrics loop 提供證據；目標是讓 MTK 知道 mobile producer-consumer 的瓶頸與優化方向。</a:t>
             </a:r>
           </a:p>
         </p:txBody>
@@ -5745,7 +5745,7 @@
                 </a:solidFill>
                 <a:latin typeface="Microsoft JhengHei"/>
               </a:rPr>
-              <a:t>判斷原則：新架構必須能解釋 profiling 中無法靠 shader micro-optimization 消掉的成本。</a:t>
+              <a:t>判斷原則：optimization 必須對應到可量測瓶頸，而不是只留下最快版本。</a:t>
             </a:r>
           </a:p>
         </p:txBody>

</xml_diff>